<commit_message>
Update pitch deck for domain research skills
</commit_message>
<xml_diff>
--- a/docs/argus_skill_auto_research_pitch.pptx
+++ b/docs/argus_skill_auto_research_pitch.pptx
@@ -4435,7 +4435,7 @@
                 </a:solidFill>
                 <a:latin typeface="Aptos"/>
               </a:rPr>
-              <a:t>29 built-in skills</a:t>
+              <a:t>34 built-in skills</a:t>
             </a:r>
           </a:p>
         </p:txBody>
@@ -4470,7 +4470,7 @@
                 </a:solidFill>
                 <a:latin typeface="Aptos"/>
               </a:rPr>
-              <a:t>Ideation, grounding, benchmark runs, ablations, claims, figures, drafting, review, assurance.</a:t>
+              <a:t>Domain router plus ideation, grounding, benchmark runs, ablations, claims, figures, drafting, review, assurance.</a:t>
             </a:r>
           </a:p>
         </p:txBody>
@@ -7866,7 +7866,7 @@
               </a:defRPr>
             </a:pPr>
             <a:r>
-              <a:t>Package a repeatable “new EMNLP project” entrypoint for future students and agents.</a:t>
+              <a:t>Package repeatable entrypoints across EMNLP, CV, multimodal, AI infrastructure, and training-based research.</a:t>
             </a:r>
           </a:p>
         </p:txBody>

</xml_diff>